<commit_message>
paper+talk+deck: credit second-model work as 'peer replication' (their requested crediting, confirmed 2026-06-12)
Resolves the acknowledgements placeholder; deck rebuilt with updated
table header and notes.

Co-Authored-By: Claude Fable 5 <noreply@anthropic.com>
</commit_message>
<xml_diff>
--- a/project/capstone/paper/slides/TALK_8MIN.pptx
+++ b/project/capstone/paper/slides/TALK_8MIN.pptx
@@ -580,7 +580,7 @@
           <a:lstStyle/>
           <a:p>
             <a:r>
-              <a:t>Safety monitoring wants per-concept detectors — lenses — over families of related behaviours. These concepts aren't independent: manipulation, deception, sycophancy form a graph. The hypothesis we inherited from a collaborating interpretability project: relationship-aware training improves detection, and if two concepts are connected by many independent paths, you can triangulate their boundary even without direct data. Intuitive, testable, and if true, very useful: graphs are cheap, data is not. (1:00)</a:t>
+              <a:t>Safety monitoring wants per-concept detectors — lenses — over families of related behaviours. These concepts aren't independent: manipulation, deception, sycophancy form a graph. The hypothesis we inherited — later peer-replicated on a second model: relationship-aware training improves detection, and if two concepts are connected by many independent paths, you can triangulate their boundary even without direct data. Intuitive, testable, and if true, very useful: graphs are cheap, data is not. (1:00)</a:t>
             </a:r>
           </a:p>
         </p:txBody>
@@ -790,7 +790,7 @@
           <a:lstStyle/>
           <a:p>
             <a:r>
-              <a:t>Our collaborator's diagnosis: the mechanism isn't extra positives, it's hard negatives — train Manipulation's probe with its actual siblings as the negative class. That works: +0.06 F1, and the declared graph beats shuffled placebo graphs at p=0.002 — the curated edges are real confusability structure, not just 'any graph'. Two honest bounds: about a third of the effect is shared vocabulary, and — right column — the effect lives entirely in DIRECT adjacency. Same numbers, two models, two codebases, fully independent runs. (1:15)</a:t>
+              <a:t>The peer replication's diagnosis: the mechanism isn't extra positives, it's hard negatives — train Manipulation's probe with its actual siblings as the negative class. That works: +0.06 F1, and the declared graph beats shuffled placebo graphs at p=0.002 — the curated edges are real confusability structure, not just 'any graph'. Two honest bounds: about a third of the effect is shared vocabulary, and — right column — the effect lives entirely in DIRECT adjacency. Same numbers, two models, two codebases, fully independent runs. (1:15)</a:t>
             </a:r>
           </a:p>
         </p:txBody>
@@ -4868,7 +4868,7 @@
                         </a:defRPr>
                       </a:pPr>
                       <a:r>
-                        <a:t>E4B (independent replication)</a:t>
+                        <a:t>E4B (peer replication)</a:t>
                       </a:r>
                     </a:p>
                   </a:txBody>

</xml_diff>